<commit_message>
Update report and slides with real MP-QUIC/TQUIC results, remove stale two-week/in-progress framing
</commit_message>
<xml_diff>
--- a/ppt/MPTCP_vs_MPQUIC.pptx
+++ b/ppt/MPTCP_vs_MPQUIC.pptx
@@ -2580,7 +2580,7 @@
                 <a:ea typeface="Calibri" pitchFamily="34" charset="-122"/>
                 <a:cs typeface="Calibri" pitchFamily="34" charset="-120"/>
               </a:rPr>
-              <a:t>MPTCP was fully implemented and measured across four controlled experiments (symmetric paths, asymmetric paths, packet loss, and mid-transfer path failure). MP-QUIC experiments were designed with an identical, mirrored topology for direct comparability — execution and measurement were still in progress within the project's two-week window (see Challenges Faced, slide 5). Where MP-QUIC results are not yet our own, comparisons draw on published literature, clearly marked as such.</a:t>
+              <a:t>Both MPTCP and MP-QUIC (via TQUIC, tested across MinRTT, Round Robin, and Redundant schedulers) were fully implemented and measured across four controlled experiments (symmetric paths, asymmetric paths, packet loss, and mid-transfer path failure) and three application workloads (file transfer, video, VoIP). A separate published study (De Coninck &amp; Bonaventure, CoNEXT 2017) is used only for external context, kept clearly distinct from our own measured results.</a:t>
             </a:r>
             <a:endParaRPr lang="en-US" sz="1200" dirty="0"/>
           </a:p>
@@ -5415,7 +5415,7 @@
                 <a:ea typeface="Calibri" pitchFamily="34" charset="-122"/>
                 <a:cs typeface="Calibri" pitchFamily="34" charset="-120"/>
               </a:rPr>
-              <a:t>MP-QUIC — EXPERIMENTAL DESIGN (MIRRORED, IN PROGRESS)</a:t>
+              <a:t>MP-QUIC (TQUIC) — MEASURED (4 EXPERIMENTS, 3 SCHEDULERS)</a:t>
             </a:r>
             <a:endParaRPr lang="en-US" sz="1200" dirty="0"/>
           </a:p>
@@ -5492,7 +5492,7 @@
                 <a:ea typeface="Calibri" pitchFamily="34" charset="-122"/>
                 <a:cs typeface="Calibri" pitchFamily="34" charset="-120"/>
               </a:rPr>
-              <a:t>Same topology &amp; parameters mirrored 1:1 onto MP-QUIC (E1-E4, plus an optional scheduler-comparison run E5)</a:t>
+              <a:t>Tested via TQUIC across three schedulers (MinRTT, Round Robin, Redundant) on the identical topology, plus three application workloads (file transfer, video, VoIP)</a:t>
             </a:r>
             <a:endParaRPr lang="en-US" sz="1100" dirty="0"/>
           </a:p>
@@ -5513,7 +5513,7 @@
                 <a:ea typeface="Calibri" pitchFamily="34" charset="-122"/>
                 <a:cs typeface="Calibri" pitchFamily="34" charset="-120"/>
               </a:rPr>
-              <a:t>Mechanistic prediction: a MinRTT-style scheduler has no cross-path fairness coupling, so the Path-1/Path-2 skew is expected to be sharper than MPTCP's in asymmetric runs (E2, E3)</a:t>
+              <a:t>E1-E2: all three schedulers succeeded, 60-95 Mbps depending on scheduler, skew comparable to MPTCP's under asymmetry (E2: ~91%/9% split)</a:t>
             </a:r>
             <a:endParaRPr lang="en-US" sz="1100" dirty="0"/>
           </a:p>
@@ -5534,7 +5534,7 @@
                 <a:ea typeface="Calibri" pitchFamily="34" charset="-122"/>
                 <a:cs typeface="Calibri" pitchFamily="34" charset="-120"/>
               </a:rPr>
-              <a:t>Failure recovery (E4) is expected to take slightly longer than MPTCP's measured ~1-3s, since PATH_CHALLENGE / PATH_RESPONSE validation adds a round trip before failover is confirmed</a:t>
+              <a:t>E3 (lossy): Round Robin's file transfer failed to complete in time (10.8 Mbps avg); MinRTT and Redundant both completed normally (~56 Mbps) — scheduler choice matters as much as protocol choice</a:t>
             </a:r>
             <a:endParaRPr lang="en-US" sz="1100" dirty="0"/>
           </a:p>
@@ -5555,7 +5555,7 @@
                 <a:ea typeface="Calibri" pitchFamily="34" charset="-122"/>
                 <a:cs typeface="Calibri" pitchFamily="34" charset="-120"/>
               </a:rPr>
-              <a:t>Status: designed and ready to run; execution/measurement in progress at time of submission — see Challenges Faced</a:t>
+              <a:t>E4 (failure): all three schedulers survived, recovery 1.5-2.1s, comparable to MPTCP's ~1-3s recovery</a:t>
             </a:r>
             <a:endParaRPr lang="en-US" sz="1100" dirty="0"/>
           </a:p>
@@ -6212,7 +6212,7 @@
                             <a:srgbClr val="24273B"/>
                           </a:solidFill>
                         </a:rPr>
-                        <a:t>Similar aggregation expected; sharper skew predicted (no coupled window)</a:t>
+                        <a:t>Measured comparable aggregation; scheduler choice (MinRTT / RR / Redundant) matters more than protocol choice</a:t>
                       </a:r>
                       <a:endParaRPr lang="en-US" sz="1000" dirty="0"/>
                     </a:p>
@@ -6270,7 +6270,7 @@
                             <a:srgbClr val="1C7293"/>
                           </a:solidFill>
                         </a:rPr>
-                        <a:t>Measured / Predicted</a:t>
+                        <a:t>Measured / Measured</a:t>
                       </a:r>
                       <a:endParaRPr lang="en-US" sz="950" dirty="0"/>
                     </a:p>
@@ -6460,7 +6460,7 @@
                             <a:srgbClr val="24273B"/>
                           </a:solidFill>
                         </a:rPr>
-                        <a:t>Survives path loss; probe-based (PATH_CHALLENGE) detection, expected slightly slower</a:t>
+                        <a:t>Survives path loss; probe-based (PATH_CHALLENGE) detection, 1.5-2.1s recovery measured across three schedulers</a:t>
                       </a:r>
                       <a:endParaRPr lang="en-US" sz="1000" dirty="0"/>
                     </a:p>
@@ -6518,7 +6518,7 @@
                             <a:srgbClr val="1C7293"/>
                           </a:solidFill>
                         </a:rPr>
-                        <a:t>Measured / Literature</a:t>
+                        <a:t>Measured / Measured</a:t>
                       </a:r>
                       <a:endParaRPr lang="en-US" sz="950" dirty="0"/>
                     </a:p>
@@ -7833,7 +7833,7 @@
                 <a:ea typeface="Calibri" pitchFamily="34" charset="-122"/>
                 <a:cs typeface="Calibri" pitchFamily="34" charset="-120"/>
               </a:rPr>
-              <a:t>Mirroring identical Mininet/NetEm parameters (bandwidth, delay, loss) across a kernel stack (MPTCP) and a userspace library (MP-QUIC) so results stay comparable.</a:t>
+              <a:t>Mirroring identical NetEm parameters (bandwidth, delay, loss) across a kernel stack (MPTCP) and a userspace library (MP-QUIC) so results stay comparable.</a:t>
             </a:r>
             <a:endParaRPr lang="en-US" sz="1250" dirty="0"/>
           </a:p>
@@ -7906,7 +7906,7 @@
                 <a:ea typeface="Cambria" pitchFamily="34" charset="-122"/>
                 <a:cs typeface="Cambria" pitchFamily="34" charset="-120"/>
               </a:rPr>
-              <a:t>Two-week timeline</a:t>
+              <a:t>Mininet did not behave as expected for MP-QUIC</a:t>
             </a:r>
             <a:endParaRPr lang="en-US" sz="1550" dirty="0"/>
           </a:p>
@@ -7948,7 +7948,7 @@
                 <a:ea typeface="Calibri" pitchFamily="34" charset="-122"/>
                 <a:cs typeface="Calibri" pitchFamily="34" charset="-120"/>
               </a:rPr>
-              <a:t>MPTCP experiments (E1-E4) were completed and validated. MP-QUIC experiments were fully designed and mirrored, but execution/measurement was still in progress at submission.</a:t>
+              <a:t>Initial MP-QUIC testbed attempts inside Mininet produced inconsistent path isolation and unstable TQUIC multipath behavior across runs. We moved to network namespaces and veth pairs directly, verified with Wireshark, before running the measurements reported here.</a:t>
             </a:r>
             <a:endParaRPr lang="en-US" sz="1250" dirty="0"/>
           </a:p>
@@ -8938,7 +8938,7 @@
                             <a:srgbClr val="1C7293"/>
                           </a:solidFill>
                         </a:rPr>
-                        <a:t>(literature)</a:t>
+                        <a:t>(measured)</a:t>
                       </a:r>
                       <a:endParaRPr lang="en-US" sz="1000" dirty="0"/>
                     </a:p>
@@ -9244,7 +9244,7 @@
                             <a:srgbClr val="1C7293"/>
                           </a:solidFill>
                         </a:rPr>
-                        <a:t>Survives, probe-based</a:t>
+                        <a:t>Survives, 1.5-2.1s recovery</a:t>
                       </a:r>
                       <a:endParaRPr lang="en-US" sz="1000" dirty="0"/>
                     </a:p>
@@ -9258,7 +9258,7 @@
                             <a:srgbClr val="1C7293"/>
                           </a:solidFill>
                         </a:rPr>
-                        <a:t>(literature)</a:t>
+                        <a:t>(measured)</a:t>
                       </a:r>
                       <a:endParaRPr lang="en-US" sz="1000" dirty="0"/>
                     </a:p>

</xml_diff>